<commit_message>
finished course intro and pitch
</commit_message>
<xml_diff>
--- a/lectures/QS_pitch_MDA_2026.pptx
+++ b/lectures/QS_pitch_MDA_2026.pptx
@@ -200,7 +200,7 @@
           <a:p>
             <a:fld id="{D8B1E6A8-FC53-FE4D-B8D3-A5067DBF8E42}" type="datetimeFigureOut">
               <a:rPr lang="en-NL" smtClean="0"/>
-              <a:t>26/08/2026</a:t>
+              <a:t>28/08/2026</a:t>
             </a:fld>
             <a:endParaRPr lang="en-NL"/>
           </a:p>
@@ -810,7 +810,7 @@
           <a:p>
             <a:fld id="{1A985835-CC07-6F4B-9F71-9B303C0F427C}" type="datetimeFigureOut">
               <a:rPr lang="en-US" smtClean="0"/>
-              <a:t>8/26/26</a:t>
+              <a:t>8/28/26</a:t>
             </a:fld>
             <a:endParaRPr lang="en-US"/>
           </a:p>
@@ -1008,7 +1008,7 @@
           <a:p>
             <a:fld id="{1A985835-CC07-6F4B-9F71-9B303C0F427C}" type="datetimeFigureOut">
               <a:rPr lang="en-US" smtClean="0"/>
-              <a:t>8/26/26</a:t>
+              <a:t>8/28/26</a:t>
             </a:fld>
             <a:endParaRPr lang="en-US"/>
           </a:p>
@@ -1216,7 +1216,7 @@
           <a:p>
             <a:fld id="{1A985835-CC07-6F4B-9F71-9B303C0F427C}" type="datetimeFigureOut">
               <a:rPr lang="en-US" smtClean="0"/>
-              <a:t>8/26/26</a:t>
+              <a:t>8/28/26</a:t>
             </a:fld>
             <a:endParaRPr lang="en-US"/>
           </a:p>
@@ -1414,7 +1414,7 @@
           <a:p>
             <a:fld id="{1A985835-CC07-6F4B-9F71-9B303C0F427C}" type="datetimeFigureOut">
               <a:rPr lang="en-US" smtClean="0"/>
-              <a:t>8/26/26</a:t>
+              <a:t>8/28/26</a:t>
             </a:fld>
             <a:endParaRPr lang="en-US"/>
           </a:p>
@@ -1689,7 +1689,7 @@
           <a:p>
             <a:fld id="{1A985835-CC07-6F4B-9F71-9B303C0F427C}" type="datetimeFigureOut">
               <a:rPr lang="en-US" smtClean="0"/>
-              <a:t>8/26/26</a:t>
+              <a:t>8/28/26</a:t>
             </a:fld>
             <a:endParaRPr lang="en-US"/>
           </a:p>
@@ -1954,7 +1954,7 @@
           <a:p>
             <a:fld id="{1A985835-CC07-6F4B-9F71-9B303C0F427C}" type="datetimeFigureOut">
               <a:rPr lang="en-US" smtClean="0"/>
-              <a:t>8/26/26</a:t>
+              <a:t>8/28/26</a:t>
             </a:fld>
             <a:endParaRPr lang="en-US"/>
           </a:p>
@@ -2366,7 +2366,7 @@
           <a:p>
             <a:fld id="{1A985835-CC07-6F4B-9F71-9B303C0F427C}" type="datetimeFigureOut">
               <a:rPr lang="en-US" smtClean="0"/>
-              <a:t>8/26/26</a:t>
+              <a:t>8/28/26</a:t>
             </a:fld>
             <a:endParaRPr lang="en-US"/>
           </a:p>
@@ -2507,7 +2507,7 @@
           <a:p>
             <a:fld id="{1A985835-CC07-6F4B-9F71-9B303C0F427C}" type="datetimeFigureOut">
               <a:rPr lang="en-US" smtClean="0"/>
-              <a:t>8/26/26</a:t>
+              <a:t>8/28/26</a:t>
             </a:fld>
             <a:endParaRPr lang="en-US"/>
           </a:p>
@@ -2620,7 +2620,7 @@
           <a:p>
             <a:fld id="{1A985835-CC07-6F4B-9F71-9B303C0F427C}" type="datetimeFigureOut">
               <a:rPr lang="en-US" smtClean="0"/>
-              <a:t>8/26/26</a:t>
+              <a:t>8/28/26</a:t>
             </a:fld>
             <a:endParaRPr lang="en-US"/>
           </a:p>
@@ -2931,7 +2931,7 @@
           <a:p>
             <a:fld id="{1A985835-CC07-6F4B-9F71-9B303C0F427C}" type="datetimeFigureOut">
               <a:rPr lang="en-US" smtClean="0"/>
-              <a:t>8/26/26</a:t>
+              <a:t>8/28/26</a:t>
             </a:fld>
             <a:endParaRPr lang="en-US"/>
           </a:p>
@@ -3219,7 +3219,7 @@
           <a:p>
             <a:fld id="{1A985835-CC07-6F4B-9F71-9B303C0F427C}" type="datetimeFigureOut">
               <a:rPr lang="en-US" smtClean="0"/>
-              <a:t>8/26/26</a:t>
+              <a:t>8/28/26</a:t>
             </a:fld>
             <a:endParaRPr lang="en-US"/>
           </a:p>
@@ -3460,7 +3460,7 @@
           <a:p>
             <a:fld id="{1A985835-CC07-6F4B-9F71-9B303C0F427C}" type="datetimeFigureOut">
               <a:rPr lang="en-US" smtClean="0"/>
-              <a:t>8/26/26</a:t>
+              <a:t>8/28/26</a:t>
             </a:fld>
             <a:endParaRPr lang="en-US"/>
           </a:p>
@@ -4371,8 +4371,8 @@
         </p:nvSpPr>
         <p:spPr>
           <a:xfrm>
-            <a:off x="167391" y="3042501"/>
-            <a:ext cx="6479194" cy="646331"/>
+            <a:off x="167391" y="2932575"/>
+            <a:ext cx="6479194" cy="923330"/>
           </a:xfrm>
           <a:prstGeom prst="rect">
             <a:avLst/>
@@ -4402,6 +4402,15 @@
               <a:t>Which genes are affected by a certain treatment or mutation?</a:t>
             </a:r>
           </a:p>
+          <a:p>
+            <a:pPr algn="r"/>
+            <a:r>
+              <a:rPr lang="en-US" i="1" dirty="0">
+                <a:latin typeface="Helvetica" pitchFamily="2" charset="0"/>
+              </a:rPr>
+              <a:t>How can we build gene regulatory networks?</a:t>
+            </a:r>
+          </a:p>
         </p:txBody>
       </p:sp>
       <p:sp>
@@ -4418,7 +4427,7 @@
         </p:nvSpPr>
         <p:spPr>
           <a:xfrm>
-            <a:off x="167391" y="3835730"/>
+            <a:off x="167391" y="3973363"/>
             <a:ext cx="6479194" cy="646331"/>
           </a:xfrm>
           <a:prstGeom prst="rect">
@@ -5307,7 +5316,7 @@
         </p:blipFill>
         <p:spPr>
           <a:xfrm>
-            <a:off x="6823129" y="2153453"/>
+            <a:off x="6801095" y="1734812"/>
             <a:ext cx="4535276" cy="2551093"/>
           </a:xfrm>
           <a:prstGeom prst="rect">
@@ -5360,7 +5369,7 @@
         <p:spPr>
           <a:xfrm>
             <a:off x="6244361" y="1131600"/>
-            <a:ext cx="5404236" cy="1714187"/>
+            <a:ext cx="5404236" cy="2129686"/>
           </a:xfrm>
           <a:prstGeom prst="rect">
             <a:avLst/>
@@ -5422,6 +5431,19 @@
                 <a:latin typeface="Helvetica" pitchFamily="2" charset="0"/>
               </a:rPr>
               <a:t>Aalt-Jan van Dijk (Biosystems Data Analysis, SILS)</a:t>
+            </a:r>
+          </a:p>
+          <a:p>
+            <a:pPr>
+              <a:lnSpc>
+                <a:spcPct val="150000"/>
+              </a:lnSpc>
+            </a:pPr>
+            <a:r>
+              <a:rPr lang="en-US" dirty="0">
+                <a:latin typeface="Helvetica" pitchFamily="2" charset="0"/>
+              </a:rPr>
+              <a:t>Kyran Wissink (Biosystems Data Analysis, SILS)</a:t>
             </a:r>
           </a:p>
         </p:txBody>
@@ -5522,7 +5544,7 @@
         <p:spPr>
           <a:xfrm>
             <a:off x="543403" y="3153573"/>
-            <a:ext cx="3897221" cy="883190"/>
+            <a:ext cx="1960793" cy="883190"/>
           </a:xfrm>
           <a:prstGeom prst="rect">
             <a:avLst/>
@@ -5559,7 +5581,7 @@
               <a:rPr lang="en-US" dirty="0">
                 <a:latin typeface="Helvetica" pitchFamily="2" charset="0"/>
               </a:rPr>
-              <a:t>2x assignment, 1x mini oral exam</a:t>
+              <a:t>2x assignment</a:t>
             </a:r>
           </a:p>
         </p:txBody>

</xml_diff>